<commit_message>
Clarify technical approach slide: 9-patch card, 6 fit patches, correction matrix wording
Co-Authored-By: Claude Sonnet 5.5 <noreply@anthropic.com>
Claude-Session: https://claude.ai/code/session_012RFQvmumxwpixQmCEKjkS7
</commit_message>
<xml_diff>
--- a/chromaseal/docs/ChromaSeal_Technical_Approach.pptx
+++ b/chromaseal/docs/ChromaSeal_Technical_Approach.pptx
@@ -3135,8 +3135,8 @@
         </p:nvSpPr>
         <p:spPr>
           <a:xfrm>
-            <a:off x="457200" y="841248"/>
-            <a:ext cx="11247120" cy="320040"/>
+            <a:off x="457200" y="822960"/>
+            <a:ext cx="11247120" cy="411480"/>
           </a:xfrm>
           <a:prstGeom prst="rect">
             <a:avLst/>
@@ -3155,13 +3155,13 @@
               </a:spcBef>
             </a:pPr>
             <a:r>
-              <a:rPr sz="1400" b="0" i="1">
+              <a:rPr sz="1300" b="0" i="1">
                 <a:solidFill>
                   <a:srgbClr val="555F6D"/>
                 </a:solidFill>
                 <a:latin typeface="Calibri"/>
               </a:rPr>
-              <a:t>ChromaSeal: lighting-corrected reading and tamper-evident recording of field colorimetric drug tests</a:t>
+              <a:t>Lighting-corrected reading and tamper-evident recording of field colorimetric tests · no new hardware</a:t>
             </a:r>
           </a:p>
         </p:txBody>
@@ -3174,8 +3174,8 @@
         </p:nvSpPr>
         <p:spPr>
           <a:xfrm>
-            <a:off x="266547" y="1325880"/>
-            <a:ext cx="3520440" cy="2240280"/>
+            <a:off x="266547" y="1280160"/>
+            <a:ext cx="3520440" cy="2395728"/>
           </a:xfrm>
           <a:prstGeom prst="roundRect">
             <a:avLst>
@@ -3238,7 +3238,7 @@
                 </a:solidFill>
                 <a:latin typeface="Calibri"/>
               </a:rPr>
-              <a:t>•  Signed-in officer photographs the reacted strip beside a printed 9-patch reference card</a:t>
+              <a:t>•  Officer photographs the reacted strip beside a printed 9-patch reference card</a:t>
             </a:r>
           </a:p>
           <a:p>
@@ -3254,7 +3254,7 @@
                 </a:solidFill>
                 <a:latin typeface="Calibri"/>
               </a:rPr>
-              <a:t>•  On-screen alignment guide; GPS and UTC time captured</a:t>
+              <a:t>•  Card: 3 greys · red, green, blue · 3 reagent colours</a:t>
             </a:r>
           </a:p>
           <a:p>
@@ -3270,7 +3270,23 @@
                 </a:solidFill>
                 <a:latin typeface="Calibri"/>
               </a:rPr>
-              <a:t>•  No new hardware, no change to kit chemistry</a:t>
+              <a:t>•  On-screen alignment guide; UTC time and GPS (if the phone allows)</a:t>
+            </a:r>
+          </a:p>
+          <a:p>
+            <a:pPr algn="l">
+              <a:spcBef>
+                <a:spcPts val="400"/>
+              </a:spcBef>
+            </a:pPr>
+            <a:r>
+              <a:rPr sz="1200" b="0" i="0">
+                <a:solidFill>
+                  <a:srgbClr val="1B1B1B"/>
+                </a:solidFill>
+                <a:latin typeface="Calibri"/>
+              </a:rPr>
+              <a:t>•  Card calibrated at each sign-in</a:t>
             </a:r>
           </a:p>
           <a:p>
@@ -3299,8 +3315,8 @@
         </p:nvSpPr>
         <p:spPr>
           <a:xfrm>
-            <a:off x="4335627" y="1325880"/>
-            <a:ext cx="3520440" cy="2240280"/>
+            <a:off x="4335627" y="1280160"/>
+            <a:ext cx="3520440" cy="2395728"/>
           </a:xfrm>
           <a:prstGeom prst="roundRect">
             <a:avLst>
@@ -3424,8 +3440,8 @@
         </p:nvSpPr>
         <p:spPr>
           <a:xfrm>
-            <a:off x="8404707" y="1325880"/>
-            <a:ext cx="3520440" cy="2240280"/>
+            <a:off x="8404707" y="1280160"/>
+            <a:ext cx="3520440" cy="2395728"/>
           </a:xfrm>
           <a:prstGeom prst="roundRect">
             <a:avLst>
@@ -3488,7 +3504,7 @@
                 </a:solidFill>
                 <a:latin typeface="Calibri"/>
               </a:rPr>
-              <a:t>•  sRGB → linear; median of each reference patch</a:t>
+              <a:t>•  sRGB → linear light; median colour of each patch</a:t>
             </a:r>
           </a:p>
           <a:p>
@@ -3504,7 +3520,7 @@
                 </a:solidFill>
                 <a:latin typeface="Calibri"/>
               </a:rPr>
-              <a:t>•  4×3 least-squares colour matrix fitted on 6 reference patches</a:t>
+              <a:t>•  6 of the 9 patches (3 greys + red, green, blue) reveal what the light did</a:t>
             </a:r>
           </a:p>
           <a:p>
@@ -3520,7 +3536,7 @@
                 </a:solidFill>
                 <a:latin typeface="Calibri"/>
               </a:rPr>
-              <a:t>•  Poor fit → photo rejected, never guessed</a:t>
+              <a:t>•  Least-squares colour-correction matrix: 3×3 channel mix + offset</a:t>
             </a:r>
           </a:p>
           <a:p>
@@ -3536,7 +3552,7 @@
                 </a:solidFill>
                 <a:latin typeface="Calibri"/>
               </a:rPr>
-              <a:t>•  Card calibrated at each sign-in</a:t>
+              <a:t>•  Poor fit → photo rejected, never guessed</a:t>
             </a:r>
           </a:p>
           <a:p>
@@ -3565,8 +3581,8 @@
         </p:nvSpPr>
         <p:spPr>
           <a:xfrm>
-            <a:off x="8404707" y="3794760"/>
-            <a:ext cx="3520440" cy="2240280"/>
+            <a:off x="8404707" y="3840480"/>
+            <a:ext cx="3520440" cy="2395728"/>
           </a:xfrm>
           <a:prstGeom prst="roundRect">
             <a:avLst>
@@ -3645,7 +3661,7 @@
                 </a:solidFill>
                 <a:latin typeface="Calibri"/>
               </a:rPr>
-              <a:t>•  ΔE2000 distance to Target and Unreacted (Blank) colours</a:t>
+              <a:t>•  ΔE2000 distance to the Target and Unreacted colours (from the card’s reagent patches)</a:t>
             </a:r>
           </a:p>
           <a:p>
@@ -3690,8 +3706,8 @@
         </p:nvSpPr>
         <p:spPr>
           <a:xfrm>
-            <a:off x="4335627" y="3794760"/>
-            <a:ext cx="3520440" cy="2240280"/>
+            <a:off x="4335627" y="3840480"/>
+            <a:ext cx="3520440" cy="2395728"/>
           </a:xfrm>
           <a:prstGeom prst="roundRect">
             <a:avLst>
@@ -3799,8 +3815,8 @@
         </p:nvSpPr>
         <p:spPr>
           <a:xfrm>
-            <a:off x="266547" y="3794760"/>
-            <a:ext cx="3520440" cy="2240280"/>
+            <a:off x="266547" y="3840480"/>
+            <a:ext cx="3520440" cy="2395728"/>
           </a:xfrm>
           <a:prstGeom prst="roundRect">
             <a:avLst>
@@ -3924,7 +3940,7 @@
         </p:nvSpPr>
         <p:spPr>
           <a:xfrm>
-            <a:off x="3860139" y="2263139"/>
+            <a:off x="3860139" y="2295144"/>
             <a:ext cx="402335" cy="365760"/>
           </a:xfrm>
           <a:prstGeom prst="rightArrow">
@@ -3968,7 +3984,7 @@
         </p:nvSpPr>
         <p:spPr>
           <a:xfrm>
-            <a:off x="7929219" y="2263139"/>
+            <a:off x="7929219" y="2295144"/>
             <a:ext cx="402335" cy="365760"/>
           </a:xfrm>
           <a:prstGeom prst="rightArrow">
@@ -4012,8 +4028,8 @@
         </p:nvSpPr>
         <p:spPr>
           <a:xfrm>
-            <a:off x="9982047" y="3593592"/>
-            <a:ext cx="365760" cy="173736"/>
+            <a:off x="9982047" y="3703320"/>
+            <a:ext cx="365760" cy="109728"/>
           </a:xfrm>
           <a:prstGeom prst="downArrow">
             <a:avLst/>
@@ -4056,7 +4072,7 @@
         </p:nvSpPr>
         <p:spPr>
           <a:xfrm>
-            <a:off x="7929219" y="4732020"/>
+            <a:off x="7929219" y="4855464"/>
             <a:ext cx="402335" cy="365760"/>
           </a:xfrm>
           <a:prstGeom prst="leftArrow">
@@ -4100,7 +4116,7 @@
         </p:nvSpPr>
         <p:spPr>
           <a:xfrm>
-            <a:off x="3860139" y="4732020"/>
+            <a:off x="3860139" y="4855464"/>
             <a:ext cx="402335" cy="365760"/>
           </a:xfrm>
           <a:prstGeom prst="leftArrow">
@@ -4144,8 +4160,8 @@
         </p:nvSpPr>
         <p:spPr>
           <a:xfrm>
-            <a:off x="266547" y="6144768"/>
-            <a:ext cx="11658600" cy="457200"/>
+            <a:off x="266547" y="6336792"/>
+            <a:ext cx="11658600" cy="402336"/>
           </a:xfrm>
           <a:prstGeom prst="roundRect">
             <a:avLst>

</xml_diff>